<commit_message>
Mark Qwen3.8-27B as archived in the 20-page deck (D46)
The owner says Qwen is archived, not abandoned. Slides 10-12 of v7 no
longer list it as a planned language model: the PROPOSED box now reads
"GLM API, Hermes (Qwen3.8-27B archived)", and the validator is described
as applying to LLM answers only, which matches the code (GLM/Hermes
paths call validate_qwen_answer too). D46 records the decision and
AGENTS.md follows it.

Rebuilt deck: check.py 62/62; only pages 10-12 differ from r1 and were
reviewed at full resolution. The v7 README also corrects the 9:15 time
estimate: the scripts need about 15 minutes at a normal pace.

Co-Authored-By: Claude Opus 5.5 <noreply@anthropic.com>
</commit_message>
<xml_diff>
--- a/slides/proposal_v7/FMPA_Proposal_v7.pptx
+++ b/slides/proposal_v7/FMPA_Proposal_v7.pptx
@@ -636,7 +636,7 @@
           <a:p/>
           <a:p>
             <a:r>
-              <a:t>請按編號看。①使用者以表單或自然語言提交查詢；②Agent查詢處理檢查必要資訊與單位、驗證上週價可比性，通過後呼叫③；③預測引擎唯讀載入④的公開歷史，用封存模型算出相對變化並做A與B，結果回②；②組裝附期限、截止日、來源與狀態的回答回①。使用者自願保存時走／records保存API寫入⑤，與④完全分離——保存目前由網頁另行呼叫、還不是Agent工具。實線都是目前實際存在的元件與資料流：規則式②、get_market_quote與post_forecast兩個工具、預測引擎、保存API。虛線是Proposed：LLM Planner、自主選工具、save_record工具化、GLM、Qwen、Hermes與SERVER，都還沒實作或還沒部署，而且LLM只掛在②的語言層、不用來猜菜價。</a:t>
+              <a:t>請按編號看。①使用者以表單或自然語言提交查詢；②Agent查詢處理檢查必要資訊與單位、驗證上週價可比性，通過後呼叫③；③預測引擎唯讀載入④的公開歷史，用封存模型算出相對變化並做A與B，結果回②；②組裝附期限、截止日、來源與狀態的回答回①。使用者自願保存時走／records保存API寫入⑤，與④完全分離——保存目前由網頁另行呼叫、還不是Agent工具。實線都是目前實際存在的元件與資料流：規則式②、get_market_quote與post_forecast兩個工具、預測引擎、保存API。虛線是Proposed：LLM Planner、自主選工具、save_record工具化、GLM、Hermes與SERVER，都還沒實作或還沒部署；Qwen目前封存，而且LLM只掛在②的語言層、不用來猜菜價。</a:t>
             </a:r>
           </a:p>
           <a:p/>
@@ -750,7 +750,7 @@
           <a:p/>
           <a:p>
             <a:r>
-              <a:t>這張流程圖描述目標系統，節點會標注現況。主流程：先檢查必要資訊——品項、價格、單位缺了就追問，日期沒提供則以系統今天預填、只有明示但無法解析的日期才追問；單位不能換算就拒絕並說明；有上週價才做可比性檢查，不可比就降級只剩A；公開資料目前是落後超過三天先警告、該品項該市場沒有可用特徵才明確拒絕；然後呼叫白名單工具——現在對應post_forecast，失敗就報錯不補值；回答層的模板由工具事實逐字組文，驗證器目前只掛在Qwen路徑。最後三個節點是PARTIAL：保存走／records API、還沒封裝成Agent工具；到期核對的機制有、真店真值還沒收集。右側是每個分支的具體行為。</a:t>
+              <a:t>這張流程圖描述目標系統，節點會標注現況。主流程：先檢查必要資訊——品項、價格、單位缺了就追問，日期沒提供則以系統今天預填、只有明示但無法解析的日期才追問；單位不能換算就拒絕並說明；有上週價才做可比性檢查，不可比就降級只剩A；公開資料目前是落後超過三天先警告、該品項該市場沒有可用特徵才明確拒絕；然後呼叫白名單工具——現在對應post_forecast，失敗就報錯不補值；回答層的模板由工具事實逐字組文，驗證器目前只用在LLM回答、規則模板不經過。最後三個節點是PARTIAL：保存走／records API、還沒封裝成Agent工具；到期核對的機制有、真店真值還沒收集。右側是每個分支的具體行為。</a:t>
             </a:r>
           </a:p>
           <a:p/>
@@ -859,7 +859,7 @@
           <a:p/>
           <a:p>
             <a:r>
-              <a:t>主講版把演算法壓成十步：理解、驗證、選工具、取公開資料、呼叫預測引擎、套領域規則、驗證結果、忠實解釋、自願保存、到期核對。每步標注現況：現況的固定序列對應get_market_quote與post_forecast兩個工具加模板回答——驗證器目前只掛在Qwen路徑，規則模板直接由工具事實逐字組文；保存與到期核對是PARTIAL——保存API有但還不是Agent工具、真店真值還沒收集；LLM Planner、LLM解釋與嚴格的資料過期強制拒絕屬PROPOSED。完整四十一行逐行版在AGENT_DESIGN.md。重點不變：語言模型不算菜價，數字一律出自預測引擎與驗證後的工具輸出。</a:t>
+              <a:t>主講版把演算法壓成十步：理解、驗證、選工具、取公開資料、呼叫預測引擎、套領域規則、驗證結果、忠實解釋、自願保存、到期核對。每步標注現況：現況的固定序列對應get_market_quote與post_forecast兩個工具加模板回答——驗證器目前只用在LLM回答，規則模板直接由工具事實逐字組文；保存與到期核對是PARTIAL——保存API有但還不是Agent工具、真店真值還沒收集；LLM Planner、LLM解釋與嚴格的資料過期強制拒絕屬PROPOSED。完整四十一行逐行版在AGENT_DESIGN.md。重點不變：語言模型不算菜價，數字一律出自預測引擎與驗證後的工具輸出。</a:t>
             </a:r>
           </a:p>
           <a:p/>
@@ -7784,7 +7784,7 @@
                 <a:latin typeface="Microsoft JhengHei"/>
                 <a:ea typeface="Microsoft JhengHei"/>
               </a:rPr>
-              <a:t>PROPOSED（虛線，未實作未部署）：LLM Planner／自主選工具／save_record工具化；GLM API・Qwen3.8-27B・Hermes＝②的語言層（非猜菜價）；SERVER_3090</a:t>
+              <a:t>PROPOSED（虛線，未實作未部署）：LLM Planner／自主選工具／save_record工具化；GLM API・Hermes＝②的語言層（非猜菜價；Qwen3.8-27B封存）；SERVER_3090</a:t>
             </a:r>
           </a:p>
         </p:txBody>
@@ -10506,7 +10506,7 @@
                 <a:latin typeface="Microsoft JhengHei"/>
                 <a:ea typeface="Microsoft JhengHei"/>
               </a:rPr>
-              <a:t>未標注＝CURRENT；D5＝PARTIAL（&gt;3日僅警告，無特徵才拒）；D7驗證器僅Qwen路徑</a:t>
+              <a:t>未標注＝CURRENT；D5＝PARTIAL（&gt;3日僅警告，無特徵才拒）；D7驗證器僅LLM路徑</a:t>
             </a:r>
           </a:p>
           <a:p>
@@ -12136,7 +12136,7 @@
                 <a:latin typeface="Microsoft JhengHei"/>
                 <a:ea typeface="Microsoft JhengHei"/>
               </a:rPr>
-              <a:t>CURRENT對應實際程式：parse_query／get_market_quote／post_forecast／RuleBackend模板（tests 227項；驗證器僅掛Qwen路徑）。</a:t>
+              <a:t>CURRENT對應實際程式：parse_query／get_market_quote／post_forecast／RuleBackend模板（tests 227項；驗證器僅掛LLM路徑）。</a:t>
             </a:r>
           </a:p>
           <a:p>

</xml_diff>

<commit_message>
Show the running system in the 20-page deck (v7 r3)
Slide 10 is redrawn from the deployment records: browser to the Oracle
web site, and ChatGPT/Gemini to the Cloudflare MCP Worker to the Oracle
ForecastEngine, with the limits stated on the slide (MCP is A-mode only
for the original 3 items, remote E2E 6/6 but in-app chat acceptance
pending, 57-item HGB does not beat no-change). Slides 11, 12, 18, 19
and 20 now describe that system; Qwen, GLM and Hermes are gone.

check.py 65/65 (adds no-Qwen, no retired backends, honest-limit checks).
The first rebuild failed two checks (an overflowing legend and Qwen in
the cover notes) and was fixed. 14 slides are pixel-identical to r2; the
six changed slides were reviewed at full resolution.

Co-Authored-By: Claude Opus 5.5 <noreply@anthropic.com>
</commit_message>
<xml_diff>
--- a/slides/proposal_v7/FMPA_Proposal_v7.pptx
+++ b/slides/proposal_v7/FMPA_Proposal_v7.pptx
@@ -538,7 +538,7 @@
           </a:p>
           <a:p>
             <a:r>
-              <a:t>本版為期中提案 v7（20頁）：由 v6（內容同 Proposal v5 r3）濃縮——刪除重複頁、合併資料／評估頁與兩頁結果，附錄只留引用索引，數字不變；不修改產品程式、不接線LLM後端。</a:t>
+              <a:t>本版為期中提案 v7（20頁）：由 v6（內容同 Proposal v5 r3）濃縮——刪除重複頁、合併資料／評估頁與兩頁結果，附錄只留引用索引，數字不變；r3 起第10–12、18–20頁改為目前實際運作的系統（雲端網頁＋MCP），不再列已封存或暫緩的語言模型後端。</a:t>
             </a:r>
           </a:p>
           <a:p/>
@@ -630,13 +630,13 @@
           <a:lstStyle/>
           <a:p>
             <a:r>
-              <a:t>主講 第10頁｜系統架構（五群組）</a:t>
+              <a:t>主講 第10頁｜系統架構（目前實際運作）</a:t>
             </a:r>
           </a:p>
           <a:p/>
           <a:p>
             <a:r>
-              <a:t>請按編號看。①使用者以表單或自然語言提交查詢；②Agent查詢處理檢查必要資訊與單位、驗證上週價可比性，通過後呼叫③；③預測引擎唯讀載入④的公開歷史，用封存模型算出相對變化並做A與B，結果回②；②組裝附期限、截止日、來源與狀態的回答回①。使用者自願保存時走／records保存API寫入⑤，與④完全分離——保存目前由網頁另行呼叫、還不是Agent工具。實線都是目前實際存在的元件與資料流：規則式②、get_market_quote與post_forecast兩個工具、預測引擎、保存API。虛線是Proposed：LLM Planner、自主選工具、save_record工具化、GLM、Hermes與SERVER，都還沒實作或還沒部署；Qwen目前封存，而且LLM只掛在②的語言層、不用來猜菜價。</a:t>
+              <a:t>請看目前實際運作的系統，有兩個入口。第一，一般使用者用瀏覽器打開雲端網頁，不用登入，可以查六十一個品項的七天與十四天預測，也能做A和B比較，紀錄只存在自己的瀏覽器。第二，ChatGPT或Gemini這類AI助理，透過Cloudflare上的MCP服務呼叫兩個工具：查行情和做預測；這條路只開放原本三個品項的A模式，參數格式不對就拒絕，也有流量限制。兩條路最後都進到Oracle主機上的ForecastEngine，用封存模型和唯讀的公開歷史算出結果。重點是：AI助理只負責選工具和解釋，菜價一律由ForecastEngine計算。虛線是下一步：每天更新行情、同店到期驗證和分析工具，目前都還沒上線。</a:t>
             </a:r>
           </a:p>
           <a:p/>
@@ -647,7 +647,7 @@
           </a:p>
           <a:p>
             <a:r>
-              <a:t>①→②提交、②→③計算、③→④唯讀、③→②回傳、②→①回答、②→⑤保存/查閱（保存現況經Web／records，非Agent工具）。LLM後端與工具抽象屬Proposed，不宣稱已驗收。</a:t>
+              <a:t>遠端協定實測6/6（2026-10-17，新Worker fresh-market-price-agent）；ChatGPT／Gemini介面內對話驗收待補；57品項HGB留出測試MAE未勝不變價；本機原型（規則式Agent＋/records）保留但不在圖中。</a:t>
             </a:r>
           </a:p>
           <a:p/>
@@ -658,12 +658,12 @@
           </a:p>
           <a:p>
             <a:r>
+              <a:t>[DEP1] deploy/docker/oracle/ORACLE_DOCKER_OPERATIONS.md（Oracle Docker：網頁＋ForecastEngine，61品項）；deploy/cloudflare-workers-mcp/MCP_TOOL_CONTRACT.md 與 src/contracts.js（2工具、格式檢查、限流、回傳核對）；docs/deployment/POOLED_ML_MODEL_CARD_V1.md（57品項HGB，測試MAE未勝不變價）；2026-10-17 新Worker real-remote-acceptance 6/6 PASS。</a:t>
+            </a:r>
+          </a:p>
+          <a:p>
+            <a:r>
               <a:t>[A1] src/aiot_price/api/app.py: /forecast, /agent/query, /records；src/aiot_price/agent/tools.py: AgentTools（get_market_quote、post_forecast 兩工具）＋ToolCallLimiter＋parse_query；src/aiot_price/models/predict.py: ForecastEngine；prediction_records: private/predictions。依既有原型整理；save_record 尚未封裝為 AgentTool（/records 由 Web 另呼）。</a:t>
-            </a:r>
-          </a:p>
-          <a:p>
-            <a:r>
-              <a:t>[AD1] docs/proposal_v5/AGENT_DESIGN.md：架構五群組①–⑤、工具層CURRENT／PROPOSED對照（get_market_quote/post_forecast現況；save_record工具化屬Proposed）、安全約束11條、D1–D9流程圖（節點標狀態）、Algorithm 1（主講10步＋完整41行）與Pseudocode↔實作映射。</a:t>
             </a:r>
           </a:p>
           <a:p>
@@ -750,7 +750,7 @@
           <a:p/>
           <a:p>
             <a:r>
-              <a:t>這張流程圖描述目標系統，節點會標注現況。主流程：先檢查必要資訊——品項、價格、單位缺了就追問，日期沒提供則以系統今天預填、只有明示但無法解析的日期才追問；單位不能換算就拒絕並說明；有上週價才做可比性檢查，不可比就降級只剩A；公開資料目前是落後超過三天先警告、該品項該市場沒有可用特徵才明確拒絕；然後呼叫白名單工具——現在對應post_forecast，失敗就報錯不補值；回答層的模板由工具事實逐字組文，驗證器目前只用在LLM回答、規則模板不經過。最後三個節點是PARTIAL：保存走／records API、還沒封裝成Agent工具；到期核對的機制有、真店真值還沒收集。右側是每個分支的具體行為。</a:t>
+              <a:t>這張流程圖是代理人的決策流程，節點標注目前系統的現況。主流程：先檢查必要資訊——品項、價格、單位缺了就追問，日期沒提供則以今天預填；在雲端的MCP路徑，這兩步由工具的格式檢查強制，格式不對直接拒絕。單位不能換算就拒絕並說明；有上週價才做可比性檢查，不可比就降級只剩A——B模式目前只在網頁提供。公開資料過期目前只會警告，該品項該市場沒有可用特徵才明確拒絕；然後呼叫post_forecast，失敗就報錯不補值。Worker會核對預測服務的回傳是否與參數一致；雲端的回答由ChatGPT或Gemini依工具結果組成，這段解釋的忠實度還沒驗證。最後三個節點是PARTIAL：網頁的紀錄只存在瀏覽器，同店到期真值還沒收集。</a:t>
             </a:r>
           </a:p>
           <a:p/>
@@ -761,7 +761,7 @@
           </a:p>
           <a:p>
             <a:r>
-              <a:t>流程圖為Proposed Agent Flowchart；節點標注依實際程式核對（AGENT_DESIGN §7）；「除了LLM之外全部完成」的概括不成立；嚴格資料過期hard gate屬Proposed。</a:t>
+              <a:t>節點標注依實際程式與部署核對（AGENT_DESIGN §7；Worker contracts.js、Oracle /v1 API）；嚴格資料過期hard gate屬Proposed。</a:t>
             </a:r>
           </a:p>
           <a:p/>
@@ -778,6 +778,11 @@
           <a:p>
             <a:r>
               <a:t>[A1] src/aiot_price/api/app.py: /forecast, /agent/query, /records；src/aiot_price/agent/tools.py: AgentTools（get_market_quote、post_forecast 兩工具）＋ToolCallLimiter＋parse_query；src/aiot_price/models/predict.py: ForecastEngine；prediction_records: private/predictions。依既有原型整理；save_record 尚未封裝為 AgentTool（/records 由 Web 另呼）。</a:t>
+            </a:r>
+          </a:p>
+          <a:p>
+            <a:r>
+              <a:t>[DEP1] deploy/docker/oracle/ORACLE_DOCKER_OPERATIONS.md（Oracle Docker：網頁＋ForecastEngine，61品項）；deploy/cloudflare-workers-mcp/MCP_TOOL_CONTRACT.md 與 src/contracts.js（2工具、格式檢查、限流、回傳核對）；docs/deployment/POOLED_ML_MODEL_CARD_V1.md（57品項HGB，測試MAE未勝不變價）；2026-10-17 新Worker real-remote-acceptance 6/6 PASS。</a:t>
             </a:r>
           </a:p>
           <a:p/>
@@ -859,7 +864,7 @@
           <a:p/>
           <a:p>
             <a:r>
-              <a:t>主講版把演算法壓成十步：理解、驗證、選工具、取公開資料、呼叫預測引擎、套領域規則、驗證結果、忠實解釋、自願保存、到期核對。每步標注現況：現況的固定序列對應get_market_quote與post_forecast兩個工具加模板回答——驗證器目前只用在LLM回答，規則模板直接由工具事實逐字組文；保存與到期核對是PARTIAL——保存API有但還不是Agent工具、真店真值還沒收集；LLM Planner、LLM解釋與嚴格的資料過期強制拒絕屬PROPOSED。完整四十一行逐行版在AGENT_DESIGN.md。重點不變：語言模型不算菜價，數字一律出自預測引擎與驗證後的工具輸出。</a:t>
+              <a:t>主講版把演算法壓成十步：理解、驗證、選工具、取公開資料、呼叫預測引擎、套領域規則、驗證結果、忠實解釋、自願保存、到期核對。對應目前運作的系統：雲端由ChatGPT或Gemini理解請求，經MCP在兩個白名單工具中選擇；工具參數由格式檢查把關，Worker再核對預測服務的回傳。PARTIAL有三項：AI助理解釋的忠實度還沒驗證、保存只在網頁的瀏覽器裡、同店到期真值還沒收集。完整四十一行逐行版在AGENT_DESIGN.md。重點不變：語言模型不算菜價，數字一律出自預測引擎與驗證後的工具輸出。</a:t>
             </a:r>
           </a:p>
           <a:p/>
@@ -870,7 +875,7 @@
           </a:p>
           <a:p>
             <a:r>
-              <a:t>α=0.3為固定實驗規則（未訓練）；完整版41行含Input/Output與邊界聲明見AGENT_DESIGN.md；Pseudocode↔實作映射見AGENT_DESIGN §8。</a:t>
+              <a:t>α=0.3為固定實驗規則（未訓練）；B只在網頁；完整版41行與實作映射見AGENT_DESIGN.md §8（以本機原型撰寫）。</a:t>
             </a:r>
           </a:p>
           <a:p/>
@@ -887,6 +892,11 @@
           <a:p>
             <a:r>
               <a:t>[A1] src/aiot_price/api/app.py: /forecast, /agent/query, /records；src/aiot_price/agent/tools.py: AgentTools（get_market_quote、post_forecast 兩工具）＋ToolCallLimiter＋parse_query；src/aiot_price/models/predict.py: ForecastEngine；prediction_records: private/predictions。依既有原型整理；save_record 尚未封裝為 AgentTool（/records 由 Web 另呼）。</a:t>
+            </a:r>
+          </a:p>
+          <a:p>
+            <a:r>
+              <a:t>[DEP1] deploy/docker/oracle/ORACLE_DOCKER_OPERATIONS.md（Oracle Docker：網頁＋ForecastEngine，61品項）；deploy/cloudflare-workers-mcp/MCP_TOOL_CONTRACT.md 與 src/contracts.js（2工具、格式檢查、限流、回傳核對）；docs/deployment/POOLED_ML_MODEL_CARD_V1.md（57品項HGB，測試MAE未勝不變價）；2026-10-17 新Worker real-remote-acceptance 6/6 PASS。</a:t>
             </a:r>
           </a:p>
           <a:p/>
@@ -1513,7 +1523,7 @@
           <a:p/>
           <a:p>
             <a:r>
-              <a:t>這是本機原型的歷史截圖，不是今天重新查詢。為了讓字看清楚，這頁放大上方七天的A與B。讀畫面先看期限，再看有無使用上週資訊的差異，最後看來源與實驗性提醒。畫面中的B與前面教學例數值不同，來自另一個歷史查詢，不能混成同一筆。完整保存重播、語言模型後端與外網服務仍未驗收。</a:t>
+              <a:t>這是十月三日本機原型的截圖，不是今天重新查詢；同一套介面現在已擴充部署成雲端網頁，支援六十一個品項。為了讓字看清楚，這頁放大上方七天的A與B。讀畫面先看期限，再看有無使用上週資訊的差異，最後看來源與實驗性提醒。畫面中的B與前面教學例數值不同，來自另一個歷史查詢，不能混成同一筆。</a:t>
             </a:r>
           </a:p>
           <a:p/>
@@ -1524,7 +1534,7 @@
           </a:p>
           <a:p>
             <a:r>
-              <a:t>圖片只裁切放大7天比較；原圖390×844保留原位，不改數值或日期。</a:t>
+              <a:t>圖片只裁切放大7天比較；原圖390×844保留原位，不改數值或日期；雲端網頁的紀錄只存在使用者瀏覽器。</a:t>
             </a:r>
           </a:p>
           <a:p/>
@@ -1546,6 +1556,11 @@
           <a:p>
             <a:r>
               <a:t>[P1] docs/proposal_v5/PROPOSAL.md；docs/CONTRIBUTIONS.md；TASKS.md。使用者2026-10-04指示產品代理人整合與SERVER暫緩；2026-10-08指示Proposal v5第一階段（文件與簡報，不改產品程式）。</a:t>
+            </a:r>
+          </a:p>
+          <a:p>
+            <a:r>
+              <a:t>[DEP1] deploy/docker/oracle/ORACLE_DOCKER_OPERATIONS.md（Oracle Docker：網頁＋ForecastEngine，61品項）；deploy/cloudflare-workers-mcp/MCP_TOOL_CONTRACT.md 與 src/contracts.js（2工具、格式檢查、限流、回傳核對）；docs/deployment/POOLED_ML_MODEL_CARD_V1.md（57品項HGB，測試MAE未勝不變價）；2026-10-17 新Worker real-remote-acceptance 6/6 PASS。</a:t>
             </a:r>
           </a:p>
           <a:p/>
@@ -1627,7 +1642,7 @@
           <a:p/>
           <a:p>
             <a:r>
-              <a:t>總結：我們把現場報價連到固定七天十四天的預測任務，完成公開評估、A/B原型，以及符合Domain Agent要求的架構、流程圖與虛擬碼設計。限制同樣清楚：方向未勝動量、誤差未勝不變價、同店效果還沒有證據。下一步是取得同店到期真值，回答多一筆上週價有沒有幫助。謝謝，最後一頁是引用與實作索引。</a:t>
+              <a:t>總結：我們把現場報價連到固定七天十四天的預測任務，完成公開評估，把網頁與MCP服務部署上線，也完成符合Domain Agent要求的架構、流程圖與虛擬碼設計。限制同樣清楚：方向未勝動量、誤差未勝不變價、同店效果還沒有證據，行情資料也停在十月二日。下一步是每天更新行情、取得同店到期真值，回答多一筆上週價有沒有幫助。謝謝，最後一頁是引用與實作索引。</a:t>
             </a:r>
           </a:p>
           <a:p/>
@@ -1638,7 +1653,7 @@
           </a:p>
           <a:p>
             <a:r>
-              <a:t>內容同 Proposal v5 r3（已通過獨立複審）；本版只更新名稱與版本標示，不更換題目或模型。</a:t>
+              <a:t>第10–12、18–20頁依目前實際運作的系統更新（2026-10-17）；其餘內容同 Proposal v5 r3；不更換題目或模型。</a:t>
             </a:r>
           </a:p>
           <a:p/>
@@ -1655,6 +1670,11 @@
           <a:p>
             <a:r>
               <a:t>[E1] outputs/evaluation/public/public_test_results.json: horizons.h=7 / h=14；SHA256 2d28acd2f2c3e5ce566b9095c6a85477db8faf858d9ce29e974caaedc25674b8。固定測試列，未重算模型輸出、未重訓。</a:t>
+            </a:r>
+          </a:p>
+          <a:p>
+            <a:r>
+              <a:t>[DEP1] deploy/docker/oracle/ORACLE_DOCKER_OPERATIONS.md（Oracle Docker：網頁＋ForecastEngine，61品項）；deploy/cloudflare-workers-mcp/MCP_TOOL_CONTRACT.md 與 src/contracts.js（2工具、格式檢查、限流、回傳核對）；docs/deployment/POOLED_ML_MODEL_CARD_V1.md（57品項HGB，測試MAE未勝不變價）；2026-10-17 新Worker real-remote-acceptance 6/6 PASS。</a:t>
             </a:r>
           </a:p>
           <a:p/>
@@ -6269,7 +6289,7 @@
                 <a:latin typeface="Microsoft JhengHei"/>
                 <a:ea typeface="Microsoft JhengHei"/>
               </a:rPr>
-              <a:t>系統架構：五群組①–⑤＋暫緩未來區</a:t>
+              <a:t>系統架構：目前實際運作的系統</a:t>
             </a:r>
           </a:p>
         </p:txBody>
@@ -6348,7 +6368,7 @@
                 <a:latin typeface="Microsoft JhengHei"/>
                 <a:ea typeface="Microsoft JhengHei"/>
               </a:rPr>
-              <a:t>[A1][AD1] 實線＝目前實際存在之元件與資料流；虛線＝PROPOSED（未實作/未部署）；數字為索引非順序</a:t>
+              <a:t>[DEP1][A1] 實線＝已上線並實測；虛線＝下一步（未上線）；數字為索引非順序</a:t>
             </a:r>
           </a:p>
         </p:txBody>
@@ -6404,8 +6424,8 @@
         </p:nvSpPr>
         <p:spPr>
           <a:xfrm>
-            <a:off x="685800" y="1645920"/>
-            <a:ext cx="2926080" cy="1133856"/>
+            <a:off x="685800" y="1627632"/>
+            <a:ext cx="2377440" cy="1024128"/>
           </a:xfrm>
           <a:prstGeom prst="rect">
             <a:avLst/>
@@ -6450,8 +6470,8 @@
         </p:nvSpPr>
         <p:spPr>
           <a:xfrm>
-            <a:off x="822960" y="1773936"/>
-            <a:ext cx="2651760" cy="347472"/>
+            <a:off x="777240" y="1719072"/>
+            <a:ext cx="2194560" cy="329184"/>
           </a:xfrm>
           <a:prstGeom prst="rect">
             <a:avLst/>
@@ -6473,14 +6493,14 @@
               </a:spcAft>
             </a:pPr>
             <a:r>
-              <a:rPr sz="1800" b="1">
+              <a:rPr sz="1500" b="1">
                 <a:solidFill>
                   <a:srgbClr val="222B33"/>
                 </a:solidFill>
                 <a:latin typeface="Microsoft JhengHei"/>
                 <a:ea typeface="Microsoft JhengHei"/>
               </a:rPr>
-              <a:t>① 使用者與手機</a:t>
+              <a:t>① 瀏覽器</a:t>
             </a:r>
           </a:p>
         </p:txBody>
@@ -6493,8 +6513,8 @@
         </p:nvSpPr>
         <p:spPr>
           <a:xfrm>
-            <a:off x="822960" y="2176272"/>
-            <a:ext cx="2651760" cy="420624"/>
+            <a:off x="777240" y="2084832"/>
+            <a:ext cx="2194560" cy="530352"/>
           </a:xfrm>
           <a:prstGeom prst="rect">
             <a:avLst/>
@@ -6516,14 +6536,34 @@
               </a:spcAft>
             </a:pPr>
             <a:r>
-              <a:rPr sz="1300" b="0">
+              <a:rPr sz="1150" b="0">
                 <a:solidFill>
                   <a:srgbClr val="606B74"/>
                 </a:solidFill>
                 <a:latin typeface="Microsoft JhengHei"/>
                 <a:ea typeface="Microsoft JhengHei"/>
               </a:rPr>
-              <a:t>表單＋自然語言入口</a:t>
+              <a:t>雲端網頁（免登入）</a:t>
+            </a:r>
+          </a:p>
+          <a:p>
+            <a:pPr algn="ctr">
+              <a:lnSpc>
+                <a:spcPct val="108000"/>
+              </a:lnSpc>
+              <a:spcAft>
+                <a:spcPts val="200"/>
+              </a:spcAft>
+            </a:pPr>
+            <a:r>
+              <a:rPr sz="1150" b="0">
+                <a:solidFill>
+                  <a:srgbClr val="606B74"/>
+                </a:solidFill>
+                <a:latin typeface="Microsoft JhengHei"/>
+                <a:ea typeface="Microsoft JhengHei"/>
+              </a:rPr>
+              <a:t>61品項・A／B・7／14天</a:t>
             </a:r>
           </a:p>
         </p:txBody>
@@ -6536,8 +6576,8 @@
         </p:nvSpPr>
         <p:spPr>
           <a:xfrm>
-            <a:off x="4617720" y="1645920"/>
-            <a:ext cx="2926080" cy="1133856"/>
+            <a:off x="685800" y="3090672"/>
+            <a:ext cx="2377440" cy="1024128"/>
           </a:xfrm>
           <a:prstGeom prst="rect">
             <a:avLst/>
@@ -6582,8 +6622,8 @@
         </p:nvSpPr>
         <p:spPr>
           <a:xfrm>
-            <a:off x="4754880" y="1773936"/>
-            <a:ext cx="2651760" cy="347472"/>
+            <a:off x="777240" y="3182112"/>
+            <a:ext cx="2194560" cy="329184"/>
           </a:xfrm>
           <a:prstGeom prst="rect">
             <a:avLst/>
@@ -6605,14 +6645,14 @@
               </a:spcAft>
             </a:pPr>
             <a:r>
-              <a:rPr sz="1800" b="1">
+              <a:rPr sz="1500" b="1">
                 <a:solidFill>
                   <a:srgbClr val="222B33"/>
                 </a:solidFill>
                 <a:latin typeface="Microsoft JhengHei"/>
                 <a:ea typeface="Microsoft JhengHei"/>
               </a:rPr>
-              <a:t>② Agent查詢處理</a:t>
+              <a:t>① AI助理</a:t>
             </a:r>
           </a:p>
         </p:txBody>
@@ -6625,8 +6665,8 @@
         </p:nvSpPr>
         <p:spPr>
           <a:xfrm>
-            <a:off x="4754880" y="2176272"/>
-            <a:ext cx="2651760" cy="420624"/>
+            <a:off x="777240" y="3547872"/>
+            <a:ext cx="2194560" cy="530352"/>
           </a:xfrm>
           <a:prstGeom prst="rect">
             <a:avLst/>
@@ -6648,14 +6688,34 @@
               </a:spcAft>
             </a:pPr>
             <a:r>
-              <a:rPr sz="1300" b="0">
+              <a:rPr sz="1150" b="0">
                 <a:solidFill>
                   <a:srgbClr val="606B74"/>
                 </a:solidFill>
                 <a:latin typeface="Microsoft JhengHei"/>
                 <a:ea typeface="Microsoft JhengHei"/>
               </a:rPr>
-              <a:t>規則式（LLM屬虛線）</a:t>
+              <a:t>ChatGPT／Gemini</a:t>
+            </a:r>
+          </a:p>
+          <a:p>
+            <a:pPr algn="ctr">
+              <a:lnSpc>
+                <a:spcPct val="108000"/>
+              </a:lnSpc>
+              <a:spcAft>
+                <a:spcPts val="200"/>
+              </a:spcAft>
+            </a:pPr>
+            <a:r>
+              <a:rPr sz="1150" b="0">
+                <a:solidFill>
+                  <a:srgbClr val="606B74"/>
+                </a:solidFill>
+                <a:latin typeface="Microsoft JhengHei"/>
+                <a:ea typeface="Microsoft JhengHei"/>
+              </a:rPr>
+              <a:t>選工具＋解釋</a:t>
             </a:r>
           </a:p>
         </p:txBody>
@@ -6668,8 +6728,8 @@
         </p:nvSpPr>
         <p:spPr>
           <a:xfrm>
-            <a:off x="8458200" y="1645920"/>
-            <a:ext cx="2971800" cy="1133856"/>
+            <a:off x="3931920" y="3090672"/>
+            <a:ext cx="2788920" cy="1024128"/>
           </a:xfrm>
           <a:prstGeom prst="rect">
             <a:avLst/>
@@ -6714,8 +6774,8 @@
         </p:nvSpPr>
         <p:spPr>
           <a:xfrm>
-            <a:off x="8595360" y="1773936"/>
-            <a:ext cx="2697480" cy="347472"/>
+            <a:off x="4023359" y="3182112"/>
+            <a:ext cx="2606039" cy="329184"/>
           </a:xfrm>
           <a:prstGeom prst="rect">
             <a:avLst/>
@@ -6737,14 +6797,14 @@
               </a:spcAft>
             </a:pPr>
             <a:r>
-              <a:rPr sz="1800" b="1">
+              <a:rPr sz="1500" b="1">
                 <a:solidFill>
                   <a:srgbClr val="222B33"/>
                 </a:solidFill>
                 <a:latin typeface="Microsoft JhengHei"/>
                 <a:ea typeface="Microsoft JhengHei"/>
               </a:rPr>
-              <a:t>③ 菜價計算</a:t>
+              <a:t>② MCP服務</a:t>
             </a:r>
           </a:p>
         </p:txBody>
@@ -6757,8 +6817,8 @@
         </p:nvSpPr>
         <p:spPr>
           <a:xfrm>
-            <a:off x="8595360" y="2176272"/>
-            <a:ext cx="2697480" cy="420624"/>
+            <a:off x="4023359" y="3547872"/>
+            <a:ext cx="2606039" cy="530352"/>
           </a:xfrm>
           <a:prstGeom prst="rect">
             <a:avLst/>
@@ -6780,14 +6840,34 @@
               </a:spcAft>
             </a:pPr>
             <a:r>
-              <a:rPr sz="1300" b="0">
+              <a:rPr sz="1150" b="0">
                 <a:solidFill>
                   <a:srgbClr val="606B74"/>
                 </a:solidFill>
                 <a:latin typeface="Microsoft JhengHei"/>
                 <a:ea typeface="Microsoft JhengHei"/>
               </a:rPr>
-              <a:t>ForecastEngine＋A/B</a:t>
+              <a:t>Cloudflare Worker</a:t>
+            </a:r>
+          </a:p>
+          <a:p>
+            <a:pPr algn="ctr">
+              <a:lnSpc>
+                <a:spcPct val="108000"/>
+              </a:lnSpc>
+              <a:spcAft>
+                <a:spcPts val="200"/>
+              </a:spcAft>
+            </a:pPr>
+            <a:r>
+              <a:rPr sz="1150" b="0">
+                <a:solidFill>
+                  <a:srgbClr val="606B74"/>
+                </a:solidFill>
+                <a:latin typeface="Microsoft JhengHei"/>
+                <a:ea typeface="Microsoft JhengHei"/>
+              </a:rPr>
+              <a:t>get_market_quote・post_forecast</a:t>
             </a:r>
           </a:p>
         </p:txBody>
@@ -6800,8 +6880,8 @@
         </p:nvSpPr>
         <p:spPr>
           <a:xfrm>
-            <a:off x="8458200" y="3657600"/>
-            <a:ext cx="2971800" cy="896112"/>
+            <a:off x="7315200" y="1627632"/>
+            <a:ext cx="1783080" cy="2487168"/>
           </a:xfrm>
           <a:prstGeom prst="rect">
             <a:avLst/>
@@ -6846,8 +6926,8 @@
         </p:nvSpPr>
         <p:spPr>
           <a:xfrm>
-            <a:off x="8595360" y="3785615"/>
-            <a:ext cx="2697480" cy="347472"/>
+            <a:off x="7406640" y="1719072"/>
+            <a:ext cx="1600200" cy="329184"/>
           </a:xfrm>
           <a:prstGeom prst="rect">
             <a:avLst/>
@@ -6869,14 +6949,14 @@
               </a:spcAft>
             </a:pPr>
             <a:r>
-              <a:rPr sz="1800" b="1">
+              <a:rPr sz="1500" b="1">
                 <a:solidFill>
                   <a:srgbClr val="222B33"/>
                 </a:solidFill>
                 <a:latin typeface="Microsoft JhengHei"/>
                 <a:ea typeface="Microsoft JhengHei"/>
               </a:rPr>
-              <a:t>④ 公開歷史</a:t>
+              <a:t>③ Oracle主機</a:t>
             </a:r>
           </a:p>
         </p:txBody>
@@ -6889,8 +6969,8 @@
         </p:nvSpPr>
         <p:spPr>
           <a:xfrm>
-            <a:off x="8595360" y="4187952"/>
-            <a:ext cx="2697480" cy="420624"/>
+            <a:off x="7406640" y="2084832"/>
+            <a:ext cx="1600200" cy="530352"/>
           </a:xfrm>
           <a:prstGeom prst="rect">
             <a:avLst/>
@@ -6912,14 +6992,34 @@
               </a:spcAft>
             </a:pPr>
             <a:r>
-              <a:rPr sz="1300" b="0">
+              <a:rPr sz="1150" b="0">
                 <a:solidFill>
                   <a:srgbClr val="606B74"/>
                 </a:solidFill>
                 <a:latin typeface="Microsoft JhengHei"/>
                 <a:ea typeface="Microsoft JhengHei"/>
               </a:rPr>
-              <a:t>市場均價・唯讀</a:t>
+              <a:t>Nginx（HTTPS・限流）</a:t>
+            </a:r>
+          </a:p>
+          <a:p>
+            <a:pPr algn="ctr">
+              <a:lnSpc>
+                <a:spcPct val="108000"/>
+              </a:lnSpc>
+              <a:spcAft>
+                <a:spcPts val="200"/>
+              </a:spcAft>
+            </a:pPr>
+            <a:r>
+              <a:rPr sz="1150" b="0">
+                <a:solidFill>
+                  <a:srgbClr val="606B74"/>
+                </a:solidFill>
+                <a:latin typeface="Microsoft JhengHei"/>
+                <a:ea typeface="Microsoft JhengHei"/>
+              </a:rPr>
+              <a:t>＋Docker網頁</a:t>
             </a:r>
           </a:p>
         </p:txBody>
@@ -6932,8 +7032,8 @@
         </p:nvSpPr>
         <p:spPr>
           <a:xfrm>
-            <a:off x="4617720" y="3657600"/>
-            <a:ext cx="2926080" cy="896112"/>
+            <a:off x="9555480" y="1627632"/>
+            <a:ext cx="2011680" cy="1024128"/>
           </a:xfrm>
           <a:prstGeom prst="rect">
             <a:avLst/>
@@ -6978,8 +7078,8 @@
         </p:nvSpPr>
         <p:spPr>
           <a:xfrm>
-            <a:off x="4754880" y="3785615"/>
-            <a:ext cx="2651760" cy="347472"/>
+            <a:off x="9646919" y="1719072"/>
+            <a:ext cx="1828800" cy="329184"/>
           </a:xfrm>
           <a:prstGeom prst="rect">
             <a:avLst/>
@@ -7001,14 +7101,14 @@
               </a:spcAft>
             </a:pPr>
             <a:r>
-              <a:rPr sz="1800" b="1">
+              <a:rPr sz="1500" b="1">
                 <a:solidFill>
                   <a:srgbClr val="222B33"/>
                 </a:solidFill>
                 <a:latin typeface="Microsoft JhengHei"/>
                 <a:ea typeface="Microsoft JhengHei"/>
               </a:rPr>
-              <a:t>⑤ 預測紀錄</a:t>
+              <a:t>④ ForecastEngine</a:t>
             </a:r>
           </a:p>
         </p:txBody>
@@ -7021,8 +7121,8 @@
         </p:nvSpPr>
         <p:spPr>
           <a:xfrm>
-            <a:off x="4754880" y="4187952"/>
-            <a:ext cx="2651760" cy="420624"/>
+            <a:off x="9646919" y="2084832"/>
+            <a:ext cx="1828800" cy="530352"/>
           </a:xfrm>
           <a:prstGeom prst="rect">
             <a:avLst/>
@@ -7044,28 +7144,200 @@
               </a:spcAft>
             </a:pPr>
             <a:r>
-              <a:rPr sz="1300" b="0">
+              <a:rPr sz="1150" b="0">
                 <a:solidFill>
                   <a:srgbClr val="606B74"/>
                 </a:solidFill>
                 <a:latin typeface="Microsoft JhengHei"/>
                 <a:ea typeface="Microsoft JhengHei"/>
               </a:rPr>
-              <a:t>保存API・獨立儲存</a:t>
+              <a:t>原3品項RF／HGB</a:t>
+            </a:r>
+          </a:p>
+          <a:p>
+            <a:pPr algn="ctr">
+              <a:lnSpc>
+                <a:spcPct val="108000"/>
+              </a:lnSpc>
+              <a:spcAft>
+                <a:spcPts val="200"/>
+              </a:spcAft>
+            </a:pPr>
+            <a:r>
+              <a:rPr sz="1150" b="0">
+                <a:solidFill>
+                  <a:srgbClr val="606B74"/>
+                </a:solidFill>
+                <a:latin typeface="Microsoft JhengHei"/>
+                <a:ea typeface="Microsoft JhengHei"/>
+              </a:rPr>
+              <a:t>＋57品項HGB</a:t>
+            </a:r>
+          </a:p>
+        </p:txBody>
+      </p:sp>
+      <p:sp>
+        <p:nvSpPr>
+          <p:cNvPr id="22" name="Rectangle 21"/>
+          <p:cNvSpPr/>
+          <p:nvPr/>
+        </p:nvSpPr>
+        <p:spPr>
+          <a:xfrm>
+            <a:off x="9555480" y="3090672"/>
+            <a:ext cx="2011680" cy="1024128"/>
+          </a:xfrm>
+          <a:prstGeom prst="rect">
+            <a:avLst/>
+          </a:prstGeom>
+          <a:solidFill>
+            <a:srgbClr val="FFFFFF"/>
+          </a:solidFill>
+          <a:ln w="12700">
+            <a:solidFill>
+              <a:srgbClr val="CDD4DA"/>
+            </a:solidFill>
+          </a:ln>
+          <a:effectLst/>
+        </p:spPr>
+        <p:style>
+          <a:lnRef idx="1">
+            <a:schemeClr val="accent1"/>
+          </a:lnRef>
+          <a:fillRef idx="3">
+            <a:schemeClr val="accent1"/>
+          </a:fillRef>
+          <a:effectRef idx="0">
+            <a:schemeClr val="accent1"/>
+          </a:effectRef>
+          <a:fontRef idx="minor">
+            <a:schemeClr val="lt1"/>
+          </a:fontRef>
+        </p:style>
+        <p:txBody>
+          <a:bodyPr rtlCol="0" anchor="ctr"/>
+          <a:lstStyle/>
+          <a:p>
+            <a:pPr algn="ctr"/>
+          </a:p>
+        </p:txBody>
+      </p:sp>
+      <p:sp>
+        <p:nvSpPr>
+          <p:cNvPr id="23" name="TextBox 22"/>
+          <p:cNvSpPr txBox="1"/>
+          <p:nvPr/>
+        </p:nvSpPr>
+        <p:spPr>
+          <a:xfrm>
+            <a:off x="9646919" y="3182112"/>
+            <a:ext cx="1828800" cy="329184"/>
+          </a:xfrm>
+          <a:prstGeom prst="rect">
+            <a:avLst/>
+          </a:prstGeom>
+          <a:noFill/>
+        </p:spPr>
+        <p:txBody>
+          <a:bodyPr wrap="square" lIns="0" rIns="0" tIns="0" bIns="0" anchor="t">
+            <a:spAutoFit/>
+          </a:bodyPr>
+          <a:lstStyle/>
+          <a:p>
+            <a:pPr algn="ctr">
+              <a:lnSpc>
+                <a:spcPct val="116000"/>
+              </a:lnSpc>
+              <a:spcAft>
+                <a:spcPts val="200"/>
+              </a:spcAft>
+            </a:pPr>
+            <a:r>
+              <a:rPr sz="1500" b="1">
+                <a:solidFill>
+                  <a:srgbClr val="222B33"/>
+                </a:solidFill>
+                <a:latin typeface="Microsoft JhengHei"/>
+                <a:ea typeface="Microsoft JhengHei"/>
+              </a:rPr>
+              <a:t>⑤ 公開歷史</a:t>
+            </a:r>
+          </a:p>
+        </p:txBody>
+      </p:sp>
+      <p:sp>
+        <p:nvSpPr>
+          <p:cNvPr id="24" name="TextBox 23"/>
+          <p:cNvSpPr txBox="1"/>
+          <p:nvPr/>
+        </p:nvSpPr>
+        <p:spPr>
+          <a:xfrm>
+            <a:off x="9646919" y="3547872"/>
+            <a:ext cx="1828800" cy="530352"/>
+          </a:xfrm>
+          <a:prstGeom prst="rect">
+            <a:avLst/>
+          </a:prstGeom>
+          <a:noFill/>
+        </p:spPr>
+        <p:txBody>
+          <a:bodyPr wrap="square" lIns="0" rIns="0" tIns="0" bIns="0" anchor="t">
+            <a:spAutoFit/>
+          </a:bodyPr>
+          <a:lstStyle/>
+          <a:p>
+            <a:pPr algn="ctr">
+              <a:lnSpc>
+                <a:spcPct val="108000"/>
+              </a:lnSpc>
+              <a:spcAft>
+                <a:spcPts val="200"/>
+              </a:spcAft>
+            </a:pPr>
+            <a:r>
+              <a:rPr sz="1150" b="0">
+                <a:solidFill>
+                  <a:srgbClr val="606B74"/>
+                </a:solidFill>
+                <a:latin typeface="Microsoft JhengHei"/>
+                <a:ea typeface="Microsoft JhengHei"/>
+              </a:rPr>
+              <a:t>臺中市場均價</a:t>
+            </a:r>
+          </a:p>
+          <a:p>
+            <a:pPr algn="ctr">
+              <a:lnSpc>
+                <a:spcPct val="108000"/>
+              </a:lnSpc>
+              <a:spcAft>
+                <a:spcPts val="200"/>
+              </a:spcAft>
+            </a:pPr>
+            <a:r>
+              <a:rPr sz="1150" b="0">
+                <a:solidFill>
+                  <a:srgbClr val="606B74"/>
+                </a:solidFill>
+                <a:latin typeface="Microsoft JhengHei"/>
+                <a:ea typeface="Microsoft JhengHei"/>
+              </a:rPr>
+              <a:t>唯讀・至2026-10-02</a:t>
             </a:r>
           </a:p>
         </p:txBody>
       </p:sp>
       <p:cxnSp>
         <p:nvCxnSpPr>
-          <p:cNvPr id="22" name="Connector 21"/>
+          <p:cNvPr id="25" name="Connector 24"/>
           <p:cNvCxnSpPr/>
           <p:nvPr/>
         </p:nvCxnSpPr>
         <p:spPr>
           <a:xfrm>
-            <a:off x="3611880" y="2011680"/>
-            <a:ext cx="1005840" cy="0"/>
+            <a:off x="3063240" y="2139696"/>
+            <a:ext cx="4251960" cy="0"/>
           </a:xfrm>
           <a:prstGeom prst="line">
             <a:avLst/>
@@ -7095,14 +7367,14 @@
       </p:cxnSp>
       <p:sp>
         <p:nvSpPr>
-          <p:cNvPr id="23" name="TextBox 22"/>
+          <p:cNvPr id="26" name="TextBox 25"/>
           <p:cNvSpPr txBox="1"/>
           <p:nvPr/>
         </p:nvSpPr>
         <p:spPr>
           <a:xfrm>
-            <a:off x="3639312" y="1664208"/>
-            <a:ext cx="896112" cy="274320"/>
+            <a:off x="4480560" y="1810512"/>
+            <a:ext cx="1463040" cy="274320"/>
           </a:xfrm>
           <a:prstGeom prst="rect">
             <a:avLst/>
@@ -7131,21 +7403,21 @@
                 <a:latin typeface="Microsoft JhengHei"/>
                 <a:ea typeface="Microsoft JhengHei"/>
               </a:rPr>
-              <a:t>提交</a:t>
+              <a:t>HTTPS</a:t>
             </a:r>
           </a:p>
         </p:txBody>
       </p:sp>
       <p:cxnSp>
         <p:nvCxnSpPr>
-          <p:cNvPr id="24" name="Connector 23"/>
+          <p:cNvPr id="27" name="Connector 26"/>
           <p:cNvCxnSpPr/>
           <p:nvPr/>
         </p:nvCxnSpPr>
         <p:spPr>
-          <a:xfrm flipH="1">
-            <a:off x="3611880" y="2578608"/>
-            <a:ext cx="1005840" cy="0"/>
+          <a:xfrm>
+            <a:off x="3063240" y="3602736"/>
+            <a:ext cx="868680" cy="0"/>
           </a:xfrm>
           <a:prstGeom prst="line">
             <a:avLst/>
@@ -7175,14 +7447,14 @@
       </p:cxnSp>
       <p:sp>
         <p:nvSpPr>
-          <p:cNvPr id="25" name="TextBox 24"/>
+          <p:cNvPr id="28" name="TextBox 27"/>
           <p:cNvSpPr txBox="1"/>
           <p:nvPr/>
         </p:nvSpPr>
         <p:spPr>
           <a:xfrm>
-            <a:off x="3611880" y="2834640"/>
-            <a:ext cx="1005840" cy="292608"/>
+            <a:off x="3017520" y="3273552"/>
+            <a:ext cx="960120" cy="274320"/>
           </a:xfrm>
           <a:prstGeom prst="rect">
             <a:avLst/>
@@ -7204,28 +7476,28 @@
               </a:spcAft>
             </a:pPr>
             <a:r>
-              <a:rPr sz="1200" b="0">
+              <a:rPr sz="1100" b="0">
                 <a:solidFill>
                   <a:srgbClr val="315A70"/>
                 </a:solidFill>
                 <a:latin typeface="Microsoft JhengHei"/>
                 <a:ea typeface="Microsoft JhengHei"/>
               </a:rPr>
-              <a:t>回傳結果</a:t>
+              <a:t>MCP呼叫</a:t>
             </a:r>
           </a:p>
         </p:txBody>
       </p:sp>
       <p:cxnSp>
         <p:nvCxnSpPr>
-          <p:cNvPr id="26" name="Connector 25"/>
+          <p:cNvPr id="29" name="Connector 28"/>
           <p:cNvCxnSpPr/>
           <p:nvPr/>
         </p:nvCxnSpPr>
         <p:spPr>
           <a:xfrm>
-            <a:off x="7543800" y="2011680"/>
-            <a:ext cx="914400" cy="0"/>
+            <a:off x="6720840" y="3602736"/>
+            <a:ext cx="594360" cy="0"/>
           </a:xfrm>
           <a:prstGeom prst="line">
             <a:avLst/>
@@ -7255,14 +7527,14 @@
       </p:cxnSp>
       <p:sp>
         <p:nvSpPr>
-          <p:cNvPr id="27" name="TextBox 26"/>
+          <p:cNvPr id="30" name="TextBox 29"/>
           <p:cNvSpPr txBox="1"/>
           <p:nvPr/>
         </p:nvSpPr>
         <p:spPr>
           <a:xfrm>
-            <a:off x="7543800" y="1664208"/>
-            <a:ext cx="896112" cy="274320"/>
+            <a:off x="6601968" y="3273552"/>
+            <a:ext cx="822960" cy="274320"/>
           </a:xfrm>
           <a:prstGeom prst="rect">
             <a:avLst/>
@@ -7284,28 +7556,28 @@
               </a:spcAft>
             </a:pPr>
             <a:r>
-              <a:rPr sz="1200" b="0">
+              <a:rPr sz="1100" b="0">
                 <a:solidFill>
                   <a:srgbClr val="315A70"/>
                 </a:solidFill>
                 <a:latin typeface="Microsoft JhengHei"/>
                 <a:ea typeface="Microsoft JhengHei"/>
               </a:rPr>
-              <a:t>計算</a:t>
+              <a:t>私有通道</a:t>
             </a:r>
           </a:p>
         </p:txBody>
       </p:sp>
       <p:cxnSp>
         <p:nvCxnSpPr>
-          <p:cNvPr id="28" name="Connector 27"/>
+          <p:cNvPr id="31" name="Connector 30"/>
           <p:cNvCxnSpPr/>
           <p:nvPr/>
         </p:nvCxnSpPr>
         <p:spPr>
-          <a:xfrm flipH="1">
-            <a:off x="7543800" y="2578608"/>
-            <a:ext cx="914400" cy="0"/>
+          <a:xfrm>
+            <a:off x="9098280" y="2139696"/>
+            <a:ext cx="457200" cy="0"/>
           </a:xfrm>
           <a:prstGeom prst="line">
             <a:avLst/>
@@ -7335,14 +7607,14 @@
       </p:cxnSp>
       <p:sp>
         <p:nvSpPr>
-          <p:cNvPr id="29" name="TextBox 28"/>
+          <p:cNvPr id="32" name="TextBox 31"/>
           <p:cNvSpPr txBox="1"/>
           <p:nvPr/>
         </p:nvSpPr>
         <p:spPr>
           <a:xfrm>
-            <a:off x="7516368" y="2834640"/>
-            <a:ext cx="969264" cy="292608"/>
+            <a:off x="9052560" y="1810512"/>
+            <a:ext cx="548640" cy="274320"/>
           </a:xfrm>
           <a:prstGeom prst="rect">
             <a:avLst/>
@@ -7364,28 +7636,28 @@
               </a:spcAft>
             </a:pPr>
             <a:r>
-              <a:rPr sz="1200" b="0">
+              <a:rPr sz="1100" b="0">
                 <a:solidFill>
                   <a:srgbClr val="315A70"/>
                 </a:solidFill>
                 <a:latin typeface="Microsoft JhengHei"/>
                 <a:ea typeface="Microsoft JhengHei"/>
               </a:rPr>
-              <a:t>回傳預測</a:t>
+              <a:t>預測</a:t>
             </a:r>
           </a:p>
         </p:txBody>
       </p:sp>
       <p:cxnSp>
         <p:nvCxnSpPr>
-          <p:cNvPr id="30" name="Connector 29"/>
+          <p:cNvPr id="33" name="Connector 32"/>
           <p:cNvCxnSpPr/>
           <p:nvPr/>
         </p:nvCxnSpPr>
         <p:spPr>
           <a:xfrm>
-            <a:off x="9930384" y="2779776"/>
-            <a:ext cx="0" cy="877824"/>
+            <a:off x="10561320" y="2651760"/>
+            <a:ext cx="0" cy="438912"/>
           </a:xfrm>
           <a:prstGeom prst="line">
             <a:avLst/>
@@ -7415,94 +7687,14 @@
       </p:cxnSp>
       <p:sp>
         <p:nvSpPr>
-          <p:cNvPr id="31" name="TextBox 30"/>
+          <p:cNvPr id="34" name="TextBox 33"/>
           <p:cNvSpPr txBox="1"/>
           <p:nvPr/>
         </p:nvSpPr>
         <p:spPr>
           <a:xfrm>
-            <a:off x="10085832" y="3108960"/>
-            <a:ext cx="1097280" cy="310896"/>
-          </a:xfrm>
-          <a:prstGeom prst="rect">
-            <a:avLst/>
-          </a:prstGeom>
-          <a:noFill/>
-        </p:spPr>
-        <p:txBody>
-          <a:bodyPr wrap="square" lIns="0" rIns="0" tIns="0" bIns="0" anchor="t">
-            <a:spAutoFit/>
-          </a:bodyPr>
-          <a:lstStyle/>
-          <a:p>
-            <a:pPr algn="l">
-              <a:lnSpc>
-                <a:spcPct val="116000"/>
-              </a:lnSpc>
-              <a:spcAft>
-                <a:spcPts val="200"/>
-              </a:spcAft>
-            </a:pPr>
-            <a:r>
-              <a:rPr sz="1200" b="0">
-                <a:solidFill>
-                  <a:srgbClr val="315A70"/>
-                </a:solidFill>
-                <a:latin typeface="Microsoft JhengHei"/>
-                <a:ea typeface="Microsoft JhengHei"/>
-              </a:rPr>
-              <a:t>唯讀載入</a:t>
-            </a:r>
-          </a:p>
-        </p:txBody>
-      </p:sp>
-      <p:cxnSp>
-        <p:nvCxnSpPr>
-          <p:cNvPr id="32" name="Connector 31"/>
-          <p:cNvCxnSpPr/>
-          <p:nvPr/>
-        </p:nvCxnSpPr>
-        <p:spPr>
-          <a:xfrm>
-            <a:off x="5468112" y="2779776"/>
-            <a:ext cx="0" cy="877824"/>
-          </a:xfrm>
-          <a:prstGeom prst="line">
-            <a:avLst/>
-          </a:prstGeom>
-          <a:ln w="20320">
-            <a:solidFill>
-              <a:srgbClr val="315A70"/>
-            </a:solidFill>
-            <a:tailEnd type="triangle"/>
-          </a:ln>
-          <a:effectLst/>
-        </p:spPr>
-        <p:style>
-          <a:lnRef idx="2">
-            <a:schemeClr val="accent1"/>
-          </a:lnRef>
-          <a:fillRef idx="0">
-            <a:schemeClr val="accent1"/>
-          </a:fillRef>
-          <a:effectRef idx="0">
-            <a:schemeClr val="accent1"/>
-          </a:effectRef>
-          <a:fontRef idx="minor">
-            <a:schemeClr val="tx1"/>
-          </a:fontRef>
-        </p:style>
-      </p:cxnSp>
-      <p:sp>
-        <p:nvSpPr>
-          <p:cNvPr id="33" name="TextBox 32"/>
-          <p:cNvSpPr txBox="1"/>
-          <p:nvPr/>
-        </p:nvSpPr>
-        <p:spPr>
-          <a:xfrm>
-            <a:off x="4187952" y="3090672"/>
-            <a:ext cx="1170432" cy="512064"/>
+            <a:off x="9601200" y="2724912"/>
+            <a:ext cx="896112" cy="274320"/>
           </a:xfrm>
           <a:prstGeom prst="rect">
             <a:avLst/>
@@ -7524,191 +7716,28 @@
               </a:spcAft>
             </a:pPr>
             <a:r>
-              <a:rPr sz="1200" b="0">
+              <a:rPr sz="1100" b="0">
                 <a:solidFill>
                   <a:srgbClr val="315A70"/>
                 </a:solidFill>
                 <a:latin typeface="Microsoft JhengHei"/>
                 <a:ea typeface="Microsoft JhengHei"/>
               </a:rPr>
-              <a:t>自願保存</a:t>
-            </a:r>
-          </a:p>
-        </p:txBody>
-      </p:sp>
-      <p:cxnSp>
-        <p:nvCxnSpPr>
-          <p:cNvPr id="34" name="Connector 33"/>
-          <p:cNvCxnSpPr/>
-          <p:nvPr/>
-        </p:nvCxnSpPr>
-        <p:spPr>
-          <a:xfrm flipV="1">
-            <a:off x="6675120" y="2779776"/>
-            <a:ext cx="0" cy="877824"/>
-          </a:xfrm>
-          <a:prstGeom prst="line">
-            <a:avLst/>
-          </a:prstGeom>
-          <a:ln w="20320">
-            <a:solidFill>
-              <a:srgbClr val="315A70"/>
-            </a:solidFill>
-            <a:tailEnd type="triangle"/>
-          </a:ln>
-          <a:effectLst/>
-        </p:spPr>
-        <p:style>
-          <a:lnRef idx="2">
-            <a:schemeClr val="accent1"/>
-          </a:lnRef>
-          <a:fillRef idx="0">
-            <a:schemeClr val="accent1"/>
-          </a:fillRef>
-          <a:effectRef idx="0">
-            <a:schemeClr val="accent1"/>
-          </a:effectRef>
-          <a:fontRef idx="minor">
-            <a:schemeClr val="tx1"/>
-          </a:fontRef>
-        </p:style>
-      </p:cxnSp>
-      <p:sp>
-        <p:nvSpPr>
-          <p:cNvPr id="35" name="TextBox 34"/>
-          <p:cNvSpPr txBox="1"/>
-          <p:nvPr/>
-        </p:nvSpPr>
-        <p:spPr>
-          <a:xfrm>
-            <a:off x="6812280" y="3108960"/>
-            <a:ext cx="822960" cy="310896"/>
-          </a:xfrm>
-          <a:prstGeom prst="rect">
-            <a:avLst/>
-          </a:prstGeom>
-          <a:noFill/>
-        </p:spPr>
-        <p:txBody>
-          <a:bodyPr wrap="square" lIns="0" rIns="0" tIns="0" bIns="0" anchor="t">
-            <a:spAutoFit/>
-          </a:bodyPr>
-          <a:lstStyle/>
-          <a:p>
-            <a:pPr algn="l">
-              <a:lnSpc>
-                <a:spcPct val="116000"/>
-              </a:lnSpc>
-              <a:spcAft>
-                <a:spcPts val="200"/>
-              </a:spcAft>
-            </a:pPr>
-            <a:r>
-              <a:rPr sz="1200" b="0">
-                <a:solidFill>
-                  <a:srgbClr val="315A70"/>
-                </a:solidFill>
-                <a:latin typeface="Microsoft JhengHei"/>
-                <a:ea typeface="Microsoft JhengHei"/>
-              </a:rPr>
-              <a:t>查閱</a:t>
-            </a:r>
-          </a:p>
-        </p:txBody>
-      </p:sp>
-      <p:sp>
-        <p:nvSpPr>
-          <p:cNvPr id="36" name="TextBox 35"/>
-          <p:cNvSpPr txBox="1"/>
-          <p:nvPr/>
-        </p:nvSpPr>
-        <p:spPr>
-          <a:xfrm>
-            <a:off x="685800" y="3017520"/>
-            <a:ext cx="2926080" cy="822960"/>
-          </a:xfrm>
-          <a:prstGeom prst="rect">
-            <a:avLst/>
-          </a:prstGeom>
-          <a:noFill/>
-        </p:spPr>
-        <p:txBody>
-          <a:bodyPr wrap="square" lIns="0" rIns="0" tIns="0" bIns="0" anchor="t">
-            <a:spAutoFit/>
-          </a:bodyPr>
-          <a:lstStyle/>
-          <a:p>
-            <a:pPr algn="l">
-              <a:lnSpc>
-                <a:spcPct val="115000"/>
-              </a:lnSpc>
-              <a:spcAft>
-                <a:spcPts val="200"/>
-              </a:spcAft>
-            </a:pPr>
-            <a:r>
-              <a:rPr sz="1250" b="0">
-                <a:solidFill>
-                  <a:srgbClr val="606B74"/>
-                </a:solidFill>
-                <a:latin typeface="Microsoft JhengHei"/>
-                <a:ea typeface="Microsoft JhengHei"/>
-              </a:rPr>
-              <a:t>現況工具：get_market_quote、</a:t>
-            </a:r>
-          </a:p>
-          <a:p>
-            <a:pPr algn="l">
-              <a:lnSpc>
-                <a:spcPct val="115000"/>
-              </a:lnSpc>
-              <a:spcAft>
-                <a:spcPts val="200"/>
-              </a:spcAft>
-            </a:pPr>
-            <a:r>
-              <a:rPr sz="1250" b="0">
-                <a:solidFill>
-                  <a:srgbClr val="606B74"/>
-                </a:solidFill>
-                <a:latin typeface="Microsoft JhengHei"/>
-                <a:ea typeface="Microsoft JhengHei"/>
-              </a:rPr>
-              <a:t>post_forecast（②固定序列）；</a:t>
-            </a:r>
-          </a:p>
-          <a:p>
-            <a:pPr algn="l">
-              <a:lnSpc>
-                <a:spcPct val="115000"/>
-              </a:lnSpc>
-              <a:spcAft>
-                <a:spcPts val="200"/>
-              </a:spcAft>
-            </a:pPr>
-            <a:r>
-              <a:rPr sz="1250" b="0">
-                <a:solidFill>
-                  <a:srgbClr val="606B74"/>
-                </a:solidFill>
-                <a:latin typeface="Microsoft JhengHei"/>
-                <a:ea typeface="Microsoft JhengHei"/>
-              </a:rPr>
-              <a:t>保存經Web另呼 /records。</a:t>
-            </a:r>
-          </a:p>
-        </p:txBody>
-      </p:sp>
-      <p:sp>
-        <p:nvSpPr>
-          <p:cNvPr id="37" name="Rectangle 36"/>
+              <a:t>唯讀載入</a:t>
+            </a:r>
+          </a:p>
+        </p:txBody>
+      </p:sp>
+      <p:sp>
+        <p:nvSpPr>
+          <p:cNvPr id="35" name="Rectangle 34"/>
           <p:cNvSpPr/>
           <p:nvPr/>
         </p:nvSpPr>
         <p:spPr>
           <a:xfrm>
-            <a:off x="685800" y="4681728"/>
-            <a:ext cx="10744200" cy="713232"/>
+            <a:off x="685800" y="4315968"/>
+            <a:ext cx="10881360" cy="530352"/>
           </a:xfrm>
           <a:prstGeom prst="rect">
             <a:avLst/>
@@ -7748,14 +7777,14 @@
       </p:sp>
       <p:sp>
         <p:nvSpPr>
-          <p:cNvPr id="38" name="TextBox 37"/>
+          <p:cNvPr id="36" name="TextBox 35"/>
           <p:cNvSpPr txBox="1"/>
           <p:nvPr/>
         </p:nvSpPr>
         <p:spPr>
           <a:xfrm>
-            <a:off x="868680" y="4791456"/>
-            <a:ext cx="10378440" cy="512064"/>
+            <a:off x="868680" y="4416552"/>
+            <a:ext cx="10515600" cy="329184"/>
           </a:xfrm>
           <a:prstGeom prst="rect">
             <a:avLst/>
@@ -7784,59 +7813,84 @@
                 <a:latin typeface="Microsoft JhengHei"/>
                 <a:ea typeface="Microsoft JhengHei"/>
               </a:rPr>
-              <a:t>PROPOSED（虛線，未實作未部署）：LLM Planner／自主選工具／save_record工具化；GLM API・Hermes＝②的語言層（非猜菜價；Qwen3.8-27B封存）；SERVER_3090</a:t>
-            </a:r>
-          </a:p>
-        </p:txBody>
-      </p:sp>
-      <p:cxnSp>
-        <p:nvCxnSpPr>
-          <p:cNvPr id="39" name="Connector 38"/>
-          <p:cNvCxnSpPr/>
-          <p:nvPr/>
-        </p:nvCxnSpPr>
-        <p:spPr>
-          <a:xfrm>
-            <a:off x="6080760" y="2779776"/>
-            <a:ext cx="0" cy="1901952"/>
-          </a:xfrm>
-          <a:prstGeom prst="line">
-            <a:avLst/>
-          </a:prstGeom>
-          <a:ln w="17780">
-            <a:solidFill>
-              <a:srgbClr val="315A70"/>
-            </a:solidFill>
-            <a:prstDash val="dash"/>
-            <a:tailEnd type="triangle"/>
-          </a:ln>
-          <a:effectLst/>
-        </p:spPr>
-        <p:style>
-          <a:lnRef idx="2">
-            <a:schemeClr val="accent1"/>
-          </a:lnRef>
-          <a:fillRef idx="0">
-            <a:schemeClr val="accent1"/>
-          </a:fillRef>
-          <a:effectRef idx="0">
-            <a:schemeClr val="accent1"/>
-          </a:effectRef>
-          <a:fontRef idx="minor">
-            <a:schemeClr val="tx1"/>
-          </a:fontRef>
-        </p:style>
-      </p:cxnSp>
-      <p:sp>
-        <p:nvSpPr>
-          <p:cNvPr id="40" name="TextBox 39"/>
+              <a:t>下一步（虛線，未上線）：每天更新行情・同店A／B到期驗證・唯讀分析工具（歷史走勢、跨市場比較）</a:t>
+            </a:r>
+          </a:p>
+        </p:txBody>
+      </p:sp>
+      <p:sp>
+        <p:nvSpPr>
+          <p:cNvPr id="37" name="TextBox 36"/>
           <p:cNvSpPr txBox="1"/>
           <p:nvPr/>
         </p:nvSpPr>
         <p:spPr>
           <a:xfrm>
-            <a:off x="685800" y="5522976"/>
-            <a:ext cx="10835640" cy="310896"/>
+            <a:off x="685800" y="4937760"/>
+            <a:ext cx="10881360" cy="530352"/>
+          </a:xfrm>
+          <a:prstGeom prst="rect">
+            <a:avLst/>
+          </a:prstGeom>
+          <a:noFill/>
+        </p:spPr>
+        <p:txBody>
+          <a:bodyPr wrap="square" lIns="0" rIns="0" tIns="0" bIns="0" anchor="t">
+            <a:spAutoFit/>
+          </a:bodyPr>
+          <a:lstStyle/>
+          <a:p>
+            <a:pPr algn="l">
+              <a:lnSpc>
+                <a:spcPct val="112000"/>
+              </a:lnSpc>
+              <a:spcAft>
+                <a:spcPts val="200"/>
+              </a:spcAft>
+            </a:pPr>
+            <a:r>
+              <a:rPr sz="1150" b="0">
+                <a:solidFill>
+                  <a:srgbClr val="606B74"/>
+                </a:solidFill>
+                <a:latin typeface="Microsoft JhengHei"/>
+                <a:ea typeface="Microsoft JhengHei"/>
+              </a:rPr>
+              <a:t>網頁：61品項、A／B，紀錄只存在使用者瀏覽器。MCP：只開放原3品項的匿名A模式，不支援B與保存；遠端實測6/6，AI助理介面內對話驗收待補。</a:t>
+            </a:r>
+          </a:p>
+          <a:p>
+            <a:pPr algn="l">
+              <a:lnSpc>
+                <a:spcPct val="112000"/>
+              </a:lnSpc>
+              <a:spcAft>
+                <a:spcPts val="200"/>
+              </a:spcAft>
+            </a:pPr>
+            <a:r>
+              <a:rPr sz="1150" b="0">
+                <a:solidFill>
+                  <a:srgbClr val="606B74"/>
+                </a:solidFill>
+                <a:latin typeface="Microsoft JhengHei"/>
+                <a:ea typeface="Microsoft JhengHei"/>
+              </a:rPr>
+              <a:t>57品項HGB留出測試誤差未勝不變價（如實標示）。本機原型（規則式Agent＋/records）保留供開發，不在此圖。</a:t>
+            </a:r>
+          </a:p>
+        </p:txBody>
+      </p:sp>
+      <p:sp>
+        <p:nvSpPr>
+          <p:cNvPr id="38" name="TextBox 37"/>
+          <p:cNvSpPr txBox="1"/>
+          <p:nvPr/>
+        </p:nvSpPr>
+        <p:spPr>
+          <a:xfrm>
+            <a:off x="685800" y="5504688"/>
+            <a:ext cx="10881360" cy="274320"/>
           </a:xfrm>
           <a:prstGeom prst="rect">
             <a:avLst/>
@@ -7858,28 +7912,28 @@
               </a:spcAft>
             </a:pPr>
             <a:r>
-              <a:rPr sz="1200" b="0">
+              <a:rPr sz="1100" b="0">
                 <a:solidFill>
                   <a:srgbClr val="606B74"/>
                 </a:solidFill>
                 <a:latin typeface="Microsoft JhengHei"/>
                 <a:ea typeface="Microsoft JhengHei"/>
               </a:rPr>
-              <a:t>圖例：實線＝現況已存在（規則式②、兩工具、ForecastEngine、/records保存API）；虛線＝PROPOSED。④⑤之間無連線（公開與私人儲存分離）。</a:t>
-            </a:r>
-          </a:p>
-        </p:txBody>
-      </p:sp>
-      <p:sp>
-        <p:nvSpPr>
-          <p:cNvPr id="41" name="TextBox 40"/>
+              <a:t>圖例：實線＝已上線並實測，結果沿原路回傳；虛線＝下一步（未上線）。</a:t>
+            </a:r>
+          </a:p>
+        </p:txBody>
+      </p:sp>
+      <p:sp>
+        <p:nvSpPr>
+          <p:cNvPr id="39" name="TextBox 38"/>
           <p:cNvSpPr txBox="1"/>
           <p:nvPr/>
         </p:nvSpPr>
         <p:spPr>
           <a:xfrm>
-            <a:off x="685800" y="5943600"/>
-            <a:ext cx="10835640" cy="310896"/>
+            <a:off x="685800" y="5870448"/>
+            <a:ext cx="10881360" cy="365760"/>
           </a:xfrm>
           <a:prstGeom prst="rect">
             <a:avLst/>
@@ -7908,7 +7962,7 @@
                 <a:latin typeface="Microsoft JhengHei"/>
                 <a:ea typeface="Microsoft JhengHei"/>
               </a:rPr>
-              <a:t>LLM只進②的語言層；菜價一律由③計算——此界線不因後端替換而改變。</a:t>
+              <a:t>LLM只選工具與解釋，不算菜價；菜價一律由④ ForecastEngine計算。</a:t>
             </a:r>
           </a:p>
         </p:txBody>
@@ -8020,7 +8074,7 @@
                 <a:latin typeface="Microsoft JhengHei"/>
                 <a:ea typeface="Microsoft JhengHei"/>
               </a:rPr>
-              <a:t>查詢流程圖：十類決策分支（Proposed Agent）</a:t>
+              <a:t>查詢流程圖：十類決策分支（對應目前系統）</a:t>
             </a:r>
           </a:p>
         </p:txBody>
@@ -8099,7 +8153,7 @@
                 <a:latin typeface="Microsoft JhengHei"/>
                 <a:ea typeface="Microsoft JhengHei"/>
               </a:rPr>
-              <a:t>[AD1] 流程圖描述目標系統；節點標CURRENT／PARTIAL；未標注＝CURRENT；完整對照見AGENT_DESIGN.md §8</a:t>
+              <a:t>[AD1][DEP1] 節點標CURRENT／PARTIAL；未標注＝CURRENT；設計對照見AGENT_DESIGN.md §8</a:t>
             </a:r>
           </a:p>
         </p:txBody>
@@ -9365,7 +9419,7 @@
                 <a:latin typeface="Microsoft JhengHei"/>
                 <a:ea typeface="Microsoft JhengHei"/>
               </a:rPr>
-              <a:t>□ R1 回答＋期限＋來源＋限制標示（模板）</a:t>
+              <a:t>□ R1 回答＋期限＋來源＋限制（模板／LLM）</a:t>
             </a:r>
           </a:p>
         </p:txBody>
@@ -10383,7 +10437,7 @@
                 <a:latin typeface="Microsoft JhengHei"/>
                 <a:ea typeface="Microsoft JhengHei"/>
               </a:rPr>
-              <a:t>是→保存：走/records API（未封裝為AgentTool）</a:t>
+              <a:t>是→網頁存在瀏覽器；本機走/records；MCP不提供</a:t>
             </a:r>
           </a:p>
         </p:txBody>
@@ -10506,7 +10560,7 @@
                 <a:latin typeface="Microsoft JhengHei"/>
                 <a:ea typeface="Microsoft JhengHei"/>
               </a:rPr>
-              <a:t>未標注＝CURRENT；D5＝PARTIAL（&gt;3日僅警告，無特徵才拒）；D7驗證器僅LLM路徑</a:t>
+              <a:t>未標注＝CURRENT；D1–D2格式強制；B僅網頁；D5＝PARTIAL（過期僅警告）</a:t>
             </a:r>
           </a:p>
           <a:p>
@@ -10526,7 +10580,7 @@
                 <a:latin typeface="Microsoft JhengHei"/>
                 <a:ea typeface="Microsoft JhengHei"/>
               </a:rPr>
-              <a:t>D8/D9/T3＝PARTIAL（API與機制有，orchestration屬Proposed）；LLM＝PROPOSED</a:t>
+              <a:t>D7＝Worker核對回傳；R1雲端由LLM回答；D8/D9/T3＝PARTIAL（同店真值未收）</a:t>
             </a:r>
           </a:p>
         </p:txBody>
@@ -10803,7 +10857,7 @@
                 <a:latin typeface="Microsoft JhengHei"/>
                 <a:ea typeface="Microsoft JhengHei"/>
               </a:rPr>
-              <a:t>Input：訊息M／今日t／白名單W　Output：回答R、追問Q、受控錯誤E、凍結紀錄P。步驟標CURRENT／PARTIAL／PROPOSED。</a:t>
+              <a:t>Input：訊息M／今日t／白名單W　Output：回答R、追問Q、受控錯誤E、凍結紀錄P。步驟標CURRENT／PARTIAL（對應目前運作的系統）。</a:t>
             </a:r>
           </a:p>
         </p:txBody>
@@ -10932,7 +10986,7 @@
                 <a:latin typeface="Microsoft JhengHei"/>
                 <a:ea typeface="Microsoft JhengHei"/>
               </a:rPr>
-              <a:t>CURRENT</a:t>
+              <a:t>CURRENT（雲端：ChatGPT／Gemini）</a:t>
             </a:r>
           </a:p>
         </p:txBody>
@@ -11061,7 +11115,7 @@
                 <a:latin typeface="Microsoft JhengHei"/>
                 <a:ea typeface="Microsoft JhengHei"/>
               </a:rPr>
-              <a:t>CURRENT</a:t>
+              <a:t>CURRENT（工具格式檢查）</a:t>
             </a:r>
           </a:p>
         </p:txBody>
@@ -11185,12 +11239,12 @@
             <a:r>
               <a:rPr sz="1150" b="1">
                 <a:solidFill>
-                  <a:srgbClr val="606B74"/>
+                  <a:srgbClr val="315A70"/>
                 </a:solidFill>
                 <a:latin typeface="Microsoft JhengHei"/>
                 <a:ea typeface="Microsoft JhengHei"/>
               </a:rPr>
-              <a:t>PARTIAL（現況固定序列）</a:t>
+              <a:t>CURRENT（雲端：LLM經MCP選）</a:t>
             </a:r>
           </a:p>
         </p:txBody>
@@ -11577,7 +11631,7 @@
                 <a:latin typeface="Microsoft JhengHei"/>
                 <a:ea typeface="Microsoft JhengHei"/>
               </a:rPr>
-              <a:t>CURRENT</a:t>
+              <a:t>CURRENT（B只在網頁）</a:t>
             </a:r>
           </a:p>
         </p:txBody>
@@ -11706,7 +11760,7 @@
                 <a:latin typeface="Microsoft JhengHei"/>
                 <a:ea typeface="Microsoft JhengHei"/>
               </a:rPr>
-              <a:t>CURRENT（驗證器）</a:t>
+              <a:t>CURRENT（Worker核對回傳）</a:t>
             </a:r>
           </a:p>
         </p:txBody>
@@ -11830,12 +11884,12 @@
             <a:r>
               <a:rPr sz="1150" b="1">
                 <a:solidFill>
-                  <a:srgbClr val="7A4A21"/>
+                  <a:srgbClr val="606B74"/>
                 </a:solidFill>
                 <a:latin typeface="Microsoft JhengHei"/>
                 <a:ea typeface="Microsoft JhengHei"/>
               </a:rPr>
-              <a:t>PARTIAL（模板；LLM屬PROPOSED）</a:t>
+              <a:t>PARTIAL（LLM解釋未驗證）</a:t>
             </a:r>
           </a:p>
         </p:txBody>
@@ -11964,7 +12018,7 @@
                 <a:latin typeface="Microsoft JhengHei"/>
                 <a:ea typeface="Microsoft JhengHei"/>
               </a:rPr>
-              <a:t>PARTIAL（/records；未工具化）</a:t>
+              <a:t>PARTIAL（網頁存瀏覽器）</a:t>
             </a:r>
           </a:p>
         </p:txBody>
@@ -12093,7 +12147,7 @@
                 <a:latin typeface="Microsoft JhengHei"/>
                 <a:ea typeface="Microsoft JhengHei"/>
               </a:rPr>
-              <a:t>PARTIAL（機制有；T16真值未有）</a:t>
+              <a:t>PARTIAL（同店真值未有）</a:t>
             </a:r>
           </a:p>
         </p:txBody>
@@ -12136,7 +12190,7 @@
                 <a:latin typeface="Microsoft JhengHei"/>
                 <a:ea typeface="Microsoft JhengHei"/>
               </a:rPr>
-              <a:t>CURRENT對應實際程式：parse_query／get_market_quote／post_forecast／RuleBackend模板（tests 227項；驗證器僅掛LLM路徑）。</a:t>
+              <a:t>CURRENT：ChatGPT／Gemini → Cloudflare MCP（2工具・格式檢查・限流）→ Oracle ForecastEngine；網頁直連。</a:t>
             </a:r>
           </a:p>
           <a:p>
@@ -12156,7 +12210,7 @@
                 <a:latin typeface="Microsoft JhengHei"/>
                 <a:ea typeface="Microsoft JhengHei"/>
               </a:rPr>
-              <a:t>PARTIAL：保存走/records（未工具化）、到期機制有真值未有；PROPOSED：LLM Planner與LLM解釋、嚴格資料過期hard gate（暫緩）。</a:t>
+              <a:t>PARTIAL：LLM解釋忠實度未驗、保存只在瀏覽器、同店真值未收；PROPOSED：資料過期強制拒絕、分析工具。</a:t>
             </a:r>
           </a:p>
         </p:txBody>
@@ -17929,7 +17983,7 @@
                 <a:latin typeface="Microsoft JhengHei"/>
                 <a:ea typeface="Microsoft JhengHei"/>
               </a:rPr>
-              <a:t>原型展示</a:t>
+              <a:t>介面展示</a:t>
             </a:r>
           </a:p>
         </p:txBody>
@@ -18051,7 +18105,7 @@
                 <a:latin typeface="Microsoft JhengHei"/>
                 <a:ea typeface="Microsoft JhengHei"/>
               </a:rPr>
-              <a:t>[U1] 2026-10-03本機原型，放大上方7天結果區；非本次即時查詢</a:t>
+              <a:t>[U1][DEP1] 2026-10-03本機原型截圖；同一套介面已擴充部署為雲端網頁 161.33.19.220/web（61品項）</a:t>
             </a:r>
           </a:p>
         </p:txBody>
@@ -18868,7 +18922,7 @@
                 <a:latin typeface="Microsoft JhengHei"/>
                 <a:ea typeface="Microsoft JhengHei"/>
               </a:rPr>
-              <a:t>公開市場7／14天評估（含負向）、A／B原型與Domain Agent三種設計表示。</a:t>
+              <a:t>7／14天公開評估（含負向）；網頁與MCP已上線；Agent三種設計表示。</a:t>
             </a:r>
           </a:p>
         </p:txBody>
@@ -18997,7 +19051,7 @@
                 <a:latin typeface="Microsoft JhengHei"/>
                 <a:ea typeface="Microsoft JhengHei"/>
               </a:rPr>
-              <a:t>方向未勝動量、誤差未勝不變價、上漲召回低；同店效果零證據；LLM後端暫緩。</a:t>
+              <a:t>方向未勝動量、誤差未勝不變價、上漲召回低；同店零證據；行情只到10月2日。</a:t>
             </a:r>
           </a:p>
         </p:txBody>
@@ -19126,7 +19180,7 @@
                 <a:latin typeface="Microsoft JhengHei"/>
                 <a:ea typeface="Microsoft JhengHei"/>
               </a:rPr>
-              <a:t>取得同店到期真值回答B增益；人因與部署驗證依計畫推進。</a:t>
+              <a:t>每天更新行情；取得同店到期真值回答B增益；補AI助理實際對話驗收。</a:t>
             </a:r>
           </a:p>
         </p:txBody>
@@ -20960,7 +21014,7 @@
                 <a:latin typeface="Microsoft JhengHei"/>
                 <a:ea typeface="Microsoft JhengHei"/>
               </a:rPr>
-              <a:t>/forecast、/agent/query、/records＋ForecastEngine＋AgentTools（get_market_quote、post_forecast）＝本機原型；save_record工具化與LLM後端、SERVER、影片、發布＝Proposed／暫緩。</a:t>
+              <a:t>雲端網頁（Oracle＋Docker，61品項）與MCP服務（Cloudflare Worker，2工具）＝已上線並實測；本機原型（/forecast、/records、規則式Agent）保留；每日行情更新、同店驗證、影片、公開發布＝待做。</a:t>
             </a:r>
           </a:p>
         </p:txBody>

</xml_diff>

<commit_message>
Fix the article-table count on slide 5 (v7 r4)
The title said "精選5件" and the notes "挑五件", but the table has four
rows (R01, R02, R06, H17); the mismatch dates back to v5. check.py now
compares both counts with the table rows (r3 fails these two checks).

Co-Authored-By: Claude Opus 5.5 <noreply@anthropic.com>
</commit_message>
<xml_diff>
--- a/slides/proposal_v7/FMPA_Proposal_v7.pptx
+++ b/slides/proposal_v7/FMPA_Proposal_v7.pptx
@@ -2226,7 +2226,7 @@
           <a:p/>
           <a:p>
             <a:r>
-              <a:t>教授指定的八欄格式：問題、AI方法、領域知識、資料集、發現與限制。主講挑五件最關鍵的：兩篇學術、一個產品、一個課程前作。完整十件在ARTICLE_SUMMARY_TABLE.md。閱讀方式是把AI方法與領域知識兩欄並列——菜價預測的文獻裡，領域知識（單位、層級、季節、災後結構）與演算法同等重要。各分數屬於各自的任務與資料，不能互比。</a:t>
+              <a:t>教授指定的八欄格式：問題、AI方法、領域知識、資料集、發現與限制。主講挑四件最關鍵的：兩篇學術、一個產品、一個課程前作。完整十件在ARTICLE_SUMMARY_TABLE.md。閱讀方式是把AI方法與領域知識兩欄並列——菜價預測的文獻裡，領域知識（單位、層級、季節、災後結構）與演算法同等重要。各分數屬於各自的任務與資料，不能互比。</a:t>
             </a:r>
           </a:p>
           <a:p/>
@@ -24596,7 +24596,7 @@
                 <a:latin typeface="Microsoft JhengHei"/>
                 <a:ea typeface="Microsoft JhengHei"/>
               </a:rPr>
-              <a:t>文獻摘要表（教授八欄格式；主講精選5件）</a:t>
+              <a:t>文獻摘要表（教授八欄格式；主講精選4件）</a:t>
             </a:r>
           </a:p>
         </p:txBody>

</xml_diff>